<commit_message>
Add Module 1 data collection notebooks and update presentation slides 7-8
- Add Module1_Job_Postings.ipynb: bar chart of job postings by location
- Add Module1_Popular_Languages.ipynb: bar chart of languages by salary (descending)
- Reference both from main notebook (Step 9, Slides 7 & 8)
- Insert charts into capstone_v3.pptx slides 7 and 8
- Add source data files: job-postings.xlsx, popular-languages.csv

Co-Authored-By: Claude Sonnet 4.6 <noreply@anthropic.com>
</commit_message>
<xml_diff>
--- a/capstone-project/capstone_v3.pptx
+++ b/capstone-project/capstone_v3.pptx
@@ -5040,15 +5040,6 @@
             </a:r>
           </a:p>
           <a:p>
-            <a:pPr marL="0" indent="0">
-              <a:buNone/>
-            </a:pPr>
-            <a:endParaRPr lang="en-US" dirty="0"/>
-            <a:r>
-              <a:t/>
-            </a:r>
-          </a:p>
-          <a:p>
             <a:r>
               <a:rPr lang="en-US" dirty="0"/>
               <a:t>JavaScript is the most widely used language today (42,697 respondents)</a:t>
@@ -5100,15 +5091,6 @@
             <a:r>
               <a:rPr lang="en-US" dirty="0"/>
               <a:t>Implications</a:t>
-            </a:r>
-          </a:p>
-          <a:p>
-            <a:pPr marL="0" indent="0">
-              <a:buNone/>
-            </a:pPr>
-            <a:endParaRPr lang="en-US" dirty="0"/>
-            <a:r>
-              <a:t/>
             </a:r>
           </a:p>
           <a:p>
@@ -5205,78 +5187,6 @@
       </p:sp>
       <p:sp>
         <p:nvSpPr>
-          <p:cNvPr id="3" name="Content Placeholder 2">
-            <a:extLst>
-              <a:ext uri="{FF2B5EF4-FFF2-40B4-BE49-F238E27FC236}">
-                <a16:creationId xmlns:a16="http://schemas.microsoft.com/office/drawing/2014/main" id="{6C2B3FA5-2985-EAFB-8885-6820D4058AF4}"/>
-              </a:ext>
-            </a:extLst>
-          </p:cNvPr>
-          <p:cNvSpPr>
-            <a:spLocks noGrp="1"/>
-          </p:cNvSpPr>
-          <p:nvPr>
-            <p:ph sz="half" idx="1"/>
-          </p:nvPr>
-        </p:nvSpPr>
-        <p:spPr>
-          <a:xfrm>
-            <a:off x="813816" y="2065128"/>
-            <a:ext cx="2228642" cy="501939"/>
-          </a:xfrm>
-        </p:spPr>
-        <p:txBody>
-          <a:bodyPr/>
-          <a:lstStyle/>
-          <a:p>
-            <a:pPr marL="0" indent="0">
-              <a:buNone/>
-            </a:pPr>
-            <a:r>
-              <a:rPr lang="en-US" dirty="0"/>
-              <a:t>Current Year</a:t>
-            </a:r>
-          </a:p>
-        </p:txBody>
-      </p:sp>
-      <p:sp>
-        <p:nvSpPr>
-          <p:cNvPr id="4" name="Content Placeholder 3">
-            <a:extLst>
-              <a:ext uri="{FF2B5EF4-FFF2-40B4-BE49-F238E27FC236}">
-                <a16:creationId xmlns:a16="http://schemas.microsoft.com/office/drawing/2014/main" id="{30E0AA0B-A66B-F896-65D9-69DDA700D8E7}"/>
-              </a:ext>
-            </a:extLst>
-          </p:cNvPr>
-          <p:cNvSpPr>
-            <a:spLocks noGrp="1"/>
-          </p:cNvSpPr>
-          <p:nvPr>
-            <p:ph sz="half" idx="2"/>
-          </p:nvPr>
-        </p:nvSpPr>
-        <p:spPr>
-          <a:xfrm>
-            <a:off x="6172200" y="2065127"/>
-            <a:ext cx="1758142" cy="501939"/>
-          </a:xfrm>
-        </p:spPr>
-        <p:txBody>
-          <a:bodyPr/>
-          <a:lstStyle/>
-          <a:p>
-            <a:pPr marL="0" indent="0">
-              <a:buNone/>
-            </a:pPr>
-            <a:r>
-              <a:rPr lang="en-US" dirty="0"/>
-              <a:t>Next Year</a:t>
-            </a:r>
-          </a:p>
-        </p:txBody>
-      </p:sp>
-      <p:sp>
-        <p:nvSpPr>
           <p:cNvPr id="5" name="Content Placeholder 2">
             <a:extLst>
               <a:ext uri="{FF2B5EF4-FFF2-40B4-BE49-F238E27FC236}">
@@ -5470,14 +5380,7 @@
             <a:pPr marL="0" indent="0">
               <a:buNone/>
             </a:pPr>
-            <a:r>
-              <a:rPr lang="en-US" sz="2200" dirty="0">
-                <a:solidFill>
-                  <a:schemeClr val="tx1"/>
-                </a:solidFill>
-              </a:rPr>
-              <a:t/>
-            </a:r>
+            <a:endParaRPr/>
           </a:p>
         </p:txBody>
       </p:sp>
@@ -5676,14 +5579,7 @@
             <a:pPr marL="0" indent="0">
               <a:buNone/>
             </a:pPr>
-            <a:r>
-              <a:rPr lang="en-US" sz="2200" dirty="0">
-                <a:solidFill>
-                  <a:schemeClr val="tx1"/>
-                </a:solidFill>
-              </a:rPr>
-              <a:t/>
-            </a:r>
+            <a:endParaRPr/>
           </a:p>
         </p:txBody>
       </p:sp>
@@ -5701,7 +5597,7 @@
         </p:nvSpPr>
         <p:spPr>
           <a:xfrm>
-            <a:off x="881252" y="1476527"/>
+            <a:off x="1468392" y="1500489"/>
             <a:ext cx="10429495" cy="461665"/>
           </a:xfrm>
           <a:prstGeom prst="rect">
@@ -5867,7 +5763,9 @@
           </a:xfrm>
         </p:spPr>
         <p:txBody>
-          <a:bodyPr/>
+          <a:bodyPr>
+            <a:normAutofit lnSpcReduction="10000"/>
+          </a:bodyPr>
           <a:lstStyle/>
           <a:p>
             <a:pPr marL="0" indent="0">
@@ -5876,15 +5774,6 @@
             <a:r>
               <a:rPr lang="en-US" dirty="0"/>
               <a:t>Findings</a:t>
-            </a:r>
-          </a:p>
-          <a:p>
-            <a:pPr marL="0" indent="0">
-              <a:buNone/>
-            </a:pPr>
-            <a:endParaRPr lang="en-US" dirty="0"/>
-            <a:r>
-              <a:t/>
             </a:r>
           </a:p>
           <a:p>
@@ -5930,7 +5819,9 @@
           </a:xfrm>
         </p:spPr>
         <p:txBody>
-          <a:bodyPr/>
+          <a:bodyPr>
+            <a:normAutofit lnSpcReduction="10000"/>
+          </a:bodyPr>
           <a:lstStyle/>
           <a:p>
             <a:pPr marL="0" indent="0">
@@ -5939,15 +5830,6 @@
             <a:r>
               <a:rPr lang="en-US" dirty="0"/>
               <a:t>Implications</a:t>
-            </a:r>
-          </a:p>
-          <a:p>
-            <a:pPr marL="0" indent="0">
-              <a:buNone/>
-            </a:pPr>
-            <a:endParaRPr lang="en-US" dirty="0"/>
-            <a:r>
-              <a:t/>
             </a:r>
           </a:p>
           <a:p>
@@ -6890,7 +6772,7 @@
         </p:spPr>
         <p:txBody>
           <a:bodyPr>
-            <a:normAutofit/>
+            <a:normAutofit fontScale="92500" lnSpcReduction="10000"/>
           </a:bodyPr>
           <a:lstStyle/>
           <a:p>
@@ -6900,15 +6782,6 @@
             <a:r>
               <a:rPr lang="en-US" dirty="0"/>
               <a:t>Findings</a:t>
-            </a:r>
-          </a:p>
-          <a:p>
-            <a:pPr marL="0" indent="0">
-              <a:buNone/>
-            </a:pPr>
-            <a:endParaRPr lang="en-US" dirty="0"/>
-            <a:r>
-              <a:t/>
             </a:r>
           </a:p>
           <a:p>
@@ -6955,7 +6828,7 @@
         </p:spPr>
         <p:txBody>
           <a:bodyPr>
-            <a:normAutofit/>
+            <a:normAutofit fontScale="92500" lnSpcReduction="10000"/>
           </a:bodyPr>
           <a:lstStyle/>
           <a:p>
@@ -6965,15 +6838,6 @@
             <a:r>
               <a:rPr lang="en-US" dirty="0"/>
               <a:t>Implications</a:t>
-            </a:r>
-          </a:p>
-          <a:p>
-            <a:pPr marL="0" indent="0">
-              <a:buNone/>
-            </a:pPr>
-            <a:endParaRPr lang="en-US" dirty="0"/>
-            <a:r>
-              <a:t/>
             </a:r>
           </a:p>
           <a:p>
@@ -8757,16 +8621,10 @@
             </a:r>
           </a:p>
           <a:p>
-            <a:r>
-              <a:rPr lang="en-US" sz="2200" dirty="0"/>
-              <a:t/>
-            </a:r>
-          </a:p>
-          <a:p>
-            <a:r>
-              <a:rPr lang="en-US" sz="2200" dirty="0"/>
-              <a:t/>
-            </a:r>
+            <a:endParaRPr lang="en-US" sz="2200" dirty="0"/>
+          </a:p>
+          <a:p>
+            <a:endParaRPr lang="en-US" sz="2200" dirty="0"/>
           </a:p>
         </p:txBody>
       </p:sp>
@@ -10199,21 +10057,44 @@
               <a:buNone/>
             </a:pPr>
             <a:r>
-              <a:rPr lang="en-US" sz="2200"/>
-              <a:t>In Module 1 you have collected the job posting data using Job API in a file named “</a:t>
-            </a:r>
-            <a:r>
-              <a:rPr lang="en-IN" sz="2400"/>
-              <a:t>job-postings.xlsx</a:t>
-            </a:r>
-            <a:r>
-              <a:rPr lang="en-US" sz="2200"/>
-              <a:t>”. Present that data using a bar chart here. Order the bar chart in the descending order of the number of job postings.</a:t>
-            </a:r>
-            <a:endParaRPr lang="en-US" sz="2200" dirty="0"/>
+              <a:rPr lang="en-US" sz="2200" dirty="0"/>
+              <a:t/>
+            </a:r>
+            <a:r>
+              <a:rPr lang="en-IN" sz="2400" dirty="0"/>
+              <a:t/>
+            </a:r>
+            <a:r>
+              <a:rPr lang="en-US" sz="2200" dirty="0"/>
+              <a:t/>
+            </a:r>
           </a:p>
         </p:txBody>
       </p:sp>
+      <p:pic>
+        <p:nvPicPr>
+          <p:cNvPr id="11" name="Picture 10" descr="job_postings.png"/>
+          <p:cNvPicPr>
+            <a:picLocks noChangeAspect="1"/>
+          </p:cNvPicPr>
+          <p:nvPr/>
+        </p:nvPicPr>
+        <p:blipFill>
+          <a:blip r:embed="rId3"/>
+          <a:stretch>
+            <a:fillRect/>
+          </a:stretch>
+        </p:blipFill>
+        <p:spPr>
+          <a:xfrm>
+            <a:off x="914400" y="2191385"/>
+            <a:ext cx="10489276" cy="2862753"/>
+          </a:xfrm>
+          <a:prstGeom prst="rect">
+            <a:avLst/>
+          </a:prstGeom>
+        </p:spPr>
+      </p:pic>
     </p:spTree>
     <p:custDataLst>
       <p:tags r:id="rId1"/>
@@ -10485,21 +10366,44 @@
               <a:buNone/>
             </a:pPr>
             <a:r>
-              <a:rPr lang="en-US" sz="2200"/>
-              <a:t>In Module 1 you have collected the job postings data using web scraping in a file named “</a:t>
-            </a:r>
-            <a:r>
-              <a:rPr lang="en-IN" sz="2400"/>
-              <a:t>popular-languages.csv</a:t>
-            </a:r>
-            <a:r>
-              <a:rPr lang="en-US" sz="2200"/>
-              <a:t>”. Present that data using a bar chart here. Order the bar chart in the descending order of salary.</a:t>
-            </a:r>
-            <a:endParaRPr lang="en-US" sz="2200" dirty="0"/>
+              <a:rPr lang="en-US" sz="2200" dirty="0"/>
+              <a:t/>
+            </a:r>
+            <a:r>
+              <a:rPr lang="en-IN" sz="2400" dirty="0"/>
+              <a:t/>
+            </a:r>
+            <a:r>
+              <a:rPr lang="en-US" sz="2200" dirty="0"/>
+              <a:t/>
+            </a:r>
           </a:p>
         </p:txBody>
       </p:sp>
+      <p:pic>
+        <p:nvPicPr>
+          <p:cNvPr id="8" name="Picture 7" descr="popular_languages.png"/>
+          <p:cNvPicPr>
+            <a:picLocks noChangeAspect="1"/>
+          </p:cNvPicPr>
+          <p:nvPr/>
+        </p:nvPicPr>
+        <p:blipFill>
+          <a:blip r:embed="rId3"/>
+          <a:stretch>
+            <a:fillRect/>
+          </a:stretch>
+        </p:blipFill>
+        <p:spPr>
+          <a:xfrm>
+            <a:off x="878305" y="2191385"/>
+            <a:ext cx="10525371" cy="2862753"/>
+          </a:xfrm>
+          <a:prstGeom prst="rect">
+            <a:avLst/>
+          </a:prstGeom>
+        </p:spPr>
+      </p:pic>
     </p:spTree>
     <p:custDataLst>
       <p:tags r:id="rId1"/>
@@ -10569,78 +10473,6 @@
       </p:sp>
       <p:sp>
         <p:nvSpPr>
-          <p:cNvPr id="8" name="Content Placeholder 2">
-            <a:extLst>
-              <a:ext uri="{FF2B5EF4-FFF2-40B4-BE49-F238E27FC236}">
-                <a16:creationId xmlns:a16="http://schemas.microsoft.com/office/drawing/2014/main" id="{54B8C8AD-F58A-1F17-9CA2-E737E1949923}"/>
-              </a:ext>
-            </a:extLst>
-          </p:cNvPr>
-          <p:cNvSpPr>
-            <a:spLocks noGrp="1"/>
-          </p:cNvSpPr>
-          <p:nvPr>
-            <p:ph sz="half" idx="1"/>
-          </p:nvPr>
-        </p:nvSpPr>
-        <p:spPr>
-          <a:xfrm>
-            <a:off x="924305" y="2063170"/>
-            <a:ext cx="2228642" cy="501939"/>
-          </a:xfrm>
-        </p:spPr>
-        <p:txBody>
-          <a:bodyPr/>
-          <a:lstStyle/>
-          <a:p>
-            <a:pPr marL="0" indent="0">
-              <a:buNone/>
-            </a:pPr>
-            <a:r>
-              <a:rPr lang="en-US" dirty="0"/>
-              <a:t>Current Year</a:t>
-            </a:r>
-          </a:p>
-        </p:txBody>
-      </p:sp>
-      <p:sp>
-        <p:nvSpPr>
-          <p:cNvPr id="9" name="Content Placeholder 3">
-            <a:extLst>
-              <a:ext uri="{FF2B5EF4-FFF2-40B4-BE49-F238E27FC236}">
-                <a16:creationId xmlns:a16="http://schemas.microsoft.com/office/drawing/2014/main" id="{D9FB3B79-D3E9-99FC-ECF2-28CCBF64752F}"/>
-              </a:ext>
-            </a:extLst>
-          </p:cNvPr>
-          <p:cNvSpPr>
-            <a:spLocks noGrp="1"/>
-          </p:cNvSpPr>
-          <p:nvPr>
-            <p:ph sz="half" idx="2"/>
-          </p:nvPr>
-        </p:nvSpPr>
-        <p:spPr>
-          <a:xfrm>
-            <a:off x="6172200" y="2063170"/>
-            <a:ext cx="1758142" cy="501939"/>
-          </a:xfrm>
-        </p:spPr>
-        <p:txBody>
-          <a:bodyPr/>
-          <a:lstStyle/>
-          <a:p>
-            <a:pPr marL="0" indent="0">
-              <a:buNone/>
-            </a:pPr>
-            <a:r>
-              <a:rPr lang="en-US" dirty="0"/>
-              <a:t>Next Year</a:t>
-            </a:r>
-          </a:p>
-        </p:txBody>
-      </p:sp>
-      <p:sp>
-        <p:nvSpPr>
           <p:cNvPr id="10" name="Content Placeholder 2">
             <a:extLst>
               <a:ext uri="{FF2B5EF4-FFF2-40B4-BE49-F238E27FC236}">
@@ -10834,14 +10666,7 @@
             <a:pPr marL="0" indent="0">
               <a:buNone/>
             </a:pPr>
-            <a:r>
-              <a:rPr lang="en-US" sz="2200" dirty="0">
-                <a:solidFill>
-                  <a:schemeClr val="tx1"/>
-                </a:solidFill>
-              </a:rPr>
-              <a:t/>
-            </a:r>
+            <a:endParaRPr/>
           </a:p>
           <a:p>
             <a:pPr marL="0" indent="0">
@@ -11050,14 +10875,7 @@
             <a:pPr marL="0" indent="0">
               <a:buNone/>
             </a:pPr>
-            <a:r>
-              <a:rPr lang="en-US" sz="2200" dirty="0">
-                <a:solidFill>
-                  <a:schemeClr val="tx1"/>
-                </a:solidFill>
-              </a:rPr>
-              <a:t/>
-            </a:r>
+            <a:endParaRPr/>
           </a:p>
         </p:txBody>
       </p:sp>
@@ -11075,7 +10893,7 @@
         </p:nvSpPr>
         <p:spPr>
           <a:xfrm>
-            <a:off x="924305" y="1475244"/>
+            <a:off x="1193813" y="1340490"/>
             <a:ext cx="10429495" cy="461665"/>
           </a:xfrm>
           <a:prstGeom prst="rect">
@@ -11112,7 +10930,7 @@
         </p:blipFill>
         <p:spPr>
           <a:xfrm>
-            <a:off x="845473" y="2605804"/>
+            <a:off x="845473" y="2663554"/>
             <a:ext cx="4614949" cy="3670301"/>
           </a:xfrm>
           <a:prstGeom prst="rect">
@@ -11136,7 +10954,7 @@
         </p:blipFill>
         <p:spPr>
           <a:xfrm>
-            <a:off x="6172200" y="2605804"/>
+            <a:off x="6172200" y="2663554"/>
             <a:ext cx="4614949" cy="3670301"/>
           </a:xfrm>
           <a:prstGeom prst="rect">
@@ -11837,6 +11655,15 @@
 </file>
 
 <file path=customXml/item1.xml><?xml version="1.0" encoding="utf-8"?>
+<?mso-contentType ?>
+<FormTemplates xmlns="http://schemas.microsoft.com/sharepoint/v3/contenttype/forms">
+  <Display>DocumentLibraryForm</Display>
+  <Edit>DocumentLibraryForm</Edit>
+  <New>DocumentLibraryForm</New>
+</FormTemplates>
+</file>
+
+<file path=customXml/item2.xml><?xml version="1.0" encoding="utf-8"?>
 <ct:contentTypeSchema xmlns:ct="http://schemas.microsoft.com/office/2006/metadata/contentType" xmlns:ma="http://schemas.microsoft.com/office/2006/metadata/properties/metaAttributes" ct:_="" ma:_="" ma:contentTypeName="Document" ma:contentTypeID="0x010100EECD86F56755A646AC8AFCBCBD967F21" ma:contentTypeVersion="19" ma:contentTypeDescription="Create a new document." ma:contentTypeScope="" ma:versionID="d7279d4efbac013e02c1e816bc7f7c13">
   <xsd:schema xmlns:xsd="http://www.w3.org/2001/XMLSchema" xmlns:xs="http://www.w3.org/2001/XMLSchema" xmlns:p="http://schemas.microsoft.com/office/2006/metadata/properties" xmlns:ns2="155be751-a274-42e8-93fb-f39d3b9bccc8" xmlns:ns3="f80a141d-92ca-4d3d-9308-f7e7b1d44ce8" targetNamespace="http://schemas.microsoft.com/office/2006/metadata/properties" ma:root="true" ma:fieldsID="0a3fd1dbe83fc08387abb87098562ef0" ns2:_="" ns3:_="">
     <xsd:import namespace="155be751-a274-42e8-93fb-f39d3b9bccc8"/>
@@ -12093,15 +11920,6 @@
 </ct:contentTypeSchema>
 </file>
 
-<file path=customXml/item2.xml><?xml version="1.0" encoding="utf-8"?>
-<?mso-contentType ?>
-<FormTemplates xmlns="http://schemas.microsoft.com/sharepoint/v3/contenttype/forms">
-  <Display>DocumentLibraryForm</Display>
-  <Edit>DocumentLibraryForm</Edit>
-  <New>DocumentLibraryForm</New>
-</FormTemplates>
-</file>
-
 <file path=customXml/item3.xml><?xml version="1.0" encoding="utf-8"?>
 <p:properties xmlns:p="http://schemas.microsoft.com/office/2006/metadata/properties" xmlns:xsi="http://www.w3.org/2001/XMLSchema-instance" xmlns:pc="http://schemas.microsoft.com/office/infopath/2007/PartnerControls">
   <documentManagement>
@@ -12115,6 +11933,14 @@
 </file>
 
 <file path=customXml/itemProps1.xml><?xml version="1.0" encoding="utf-8"?>
+<ds:datastoreItem xmlns:ds="http://schemas.openxmlformats.org/officeDocument/2006/customXml" ds:itemID="{7EFDA260-DDA0-422C-B7AE-778F653FBB36}">
+  <ds:schemaRefs>
+    <ds:schemaRef ds:uri="http://schemas.microsoft.com/sharepoint/v3/contenttype/forms"/>
+  </ds:schemaRefs>
+</ds:datastoreItem>
+</file>
+
+<file path=customXml/itemProps2.xml><?xml version="1.0" encoding="utf-8"?>
 <ds:datastoreItem xmlns:ds="http://schemas.openxmlformats.org/officeDocument/2006/customXml" ds:itemID="{BEAB06F8-DBB4-44C7-AF84-8B098C8B039F}">
   <ds:schemaRefs>
     <ds:schemaRef ds:uri="http://schemas.microsoft.com/office/2006/metadata/contentType"/>
@@ -12129,14 +11955,6 @@
     <ds:schemaRef ds:uri="http://purl.org/dc/elements/1.1/"/>
     <ds:schemaRef ds:uri="http://purl.org/dc/terms/"/>
     <ds:schemaRef ds:uri="http://schemas.microsoft.com/internal/obd"/>
-  </ds:schemaRefs>
-</ds:datastoreItem>
-</file>
-
-<file path=customXml/itemProps2.xml><?xml version="1.0" encoding="utf-8"?>
-<ds:datastoreItem xmlns:ds="http://schemas.openxmlformats.org/officeDocument/2006/customXml" ds:itemID="{7EFDA260-DDA0-422C-B7AE-778F653FBB36}">
-  <ds:schemaRefs>
-    <ds:schemaRef ds:uri="http://schemas.microsoft.com/sharepoint/v3/contenttype/forms"/>
   </ds:schemaRefs>
 </ds:datastoreItem>
 </file>

</xml_diff>